<commit_message>
vnr-v2: slot-based horse selection (1-6), illustrated 2.5D board with horse pawns, laptop-only UI
Co-Authored-By: Claude Sonnet 5.5 <noreply@anthropic.com>
Claude-Session: https://claude.ai/code/session_01QTHbdfM1djtdfxn4szBzYR
</commit_message>
<xml_diff>
--- a/vnr-v2/slides/VNR202_CaNgua_Showcase_v2.pptx
+++ b/vnr-v2/slides/VNR202_CaNgua_Showcase_v2.pptx
@@ -4999,7 +4999,7 @@
                 </a:solidFill>
                 <a:latin typeface="Calibri"/>
               </a:rPr>
-              <a:t>6 đội đua cùng lúc trên một bàn cờ</a:t>
+              <a:t>6 người đua cùng lúc trên một bàn cờ</a:t>
             </a:r>
           </a:p>
           <a:p>
@@ -6982,7 +6982,7 @@
                 </a:solidFill>
                 <a:latin typeface="Calibri"/>
               </a:rPr>
-              <a:t>Cá ngựa 6 đội. Mỗi lượt đổ xúc xắc và trả lời một câu hỏi từ giáo trình. Đúng thì nhận thẻ kỹ năng để tăng tốc hoặc chặn đối thủ. Về đích trước thì thắng.</a:t>
+              <a:t>Cá ngựa 6 người chơi. Mỗi lượt đổ xúc xắc và trả lời một câu hỏi từ giáo trình. Đúng thì nhận thẻ kỹ năng để tăng tốc hoặc chặn đối thủ. Về đích trước thì thắng.</a:t>
             </a:r>
           </a:p>
         </p:txBody>
@@ -11215,7 +11215,7 @@
                 </a:solidFill>
                 <a:latin typeface="Calibri"/>
               </a:rPr>
-              <a:t> 2-6 đội, mỗi đội một thiết bị; màn chiếu riêng cho lớp; 20-30 người cùng xem/chơi.</a:t>
+              <a:t> 2-6 người chơi, mỗi người một ngựa trên một laptop; màn chiếu riêng cho lớp; 20-30 người cùng xem.</a:t>
             </a:r>
           </a:p>
         </p:txBody>
@@ -11462,7 +11462,7 @@
         <p:spPr>
           <a:xfrm>
             <a:off x="548640" y="1463040"/>
-            <a:ext cx="6217920" cy="3064546"/>
+            <a:ext cx="6309360" cy="3943350"/>
           </a:xfrm>
           <a:prstGeom prst="rect">
             <a:avLst/>
@@ -11471,7 +11471,7 @@
       </p:pic>
       <p:pic>
         <p:nvPicPr>
-          <p:cNvPr id="8" name="Picture 7" descr="_crop_05-team-mobile.png"/>
+          <p:cNvPr id="8" name="Picture 7" descr="02-lobby-host.png"/>
           <p:cNvPicPr>
             <a:picLocks noChangeAspect="1"/>
           </p:cNvPicPr>
@@ -11485,8 +11485,8 @@
         </p:blipFill>
         <p:spPr>
           <a:xfrm>
-            <a:off x="7955279" y="1371600"/>
-            <a:ext cx="1757508" cy="4937760"/>
+            <a:off x="7040880" y="1463040"/>
+            <a:ext cx="4663440" cy="2914650"/>
           </a:xfrm>
           <a:prstGeom prst="rect">
             <a:avLst/>
@@ -11543,7 +11543,7 @@
                 </a:solidFill>
                 <a:latin typeface="Calibri"/>
               </a:rPr>
-              <a:t>Mỗi đội một điện thoại: câu hỏi, 4 đáp án, thẻ kỹ năng riêng (đối thủ chỉ thấy số thẻ).</a:t>
+              <a:t>Phòng chờ: mỗi người chọn 1 trong 6 ngựa. Trên laptop của mình, người chơi thấy câu hỏi, 4 đáp án và thẻ kỹ năng riêng (đối thủ chỉ thấy số thẻ).</a:t>
             </a:r>
           </a:p>
         </p:txBody>

</xml_diff>

<commit_message>
vnr-v2: six-arm Ludo map with stables, teams of 1-6 horses, exit rolls, kicking, dice hub, card tray
Rules checked against common Ludo/co ca ngua rules: roll 1 or 6 to leave the
stable, kick sends rivals back, star cells are safe, bonus rolls, private home
lane. Engine rewritten (19 tests); diorama board with kick effect.

Co-Authored-By: Claude Sonnet 5.5 <noreply@anthropic.com>
Claude-Session: https://claude.ai/code/session_01QTHbdfM1djtdfxn4szBzYR
</commit_message>
<xml_diff>
--- a/vnr-v2/slides/VNR202_CaNgua_Showcase_v2.pptx
+++ b/vnr-v2/slides/VNR202_CaNgua_Showcase_v2.pptx
@@ -4999,7 +4999,7 @@
                 </a:solidFill>
                 <a:latin typeface="Calibri"/>
               </a:rPr>
-              <a:t>6 người đua cùng lúc trên một bàn cờ</a:t>
+              <a:t>6 đội, mỗi người một ngựa, đua trên bản đồ 6 cánh có chuồng</a:t>
             </a:r>
           </a:p>
           <a:p>
@@ -5015,7 +5015,7 @@
                 </a:solidFill>
                 <a:latin typeface="Calibri"/>
               </a:rPr>
-              <a:t>Đúng → đi + nhận thẻ; sai → đi nhưng không thẻ</a:t>
+              <a:t>Xuất chuồng khi tung 1/6, đá ngựa về chuồng, tung thêm lượt</a:t>
             </a:r>
           </a:p>
           <a:p>
@@ -5031,7 +5031,7 @@
                 </a:solidFill>
                 <a:latin typeface="Calibri"/>
               </a:rPr>
-              <a:t>10 thẻ kỹ năng: chặn đối thủ, tăng tốc, khiên, hỗ trợ</a:t>
+              <a:t>Đúng → nhận thẻ kỹ năng (10 loại) dùng chặn đối thủ</a:t>
             </a:r>
           </a:p>
           <a:p>
@@ -11165,7 +11165,7 @@
                 </a:solidFill>
                 <a:latin typeface="Calibri"/>
               </a:rPr>
-              <a:t> vòng đua chung 24 ô + đường về nhà 4 ô an toàn; đáp xuống ô có ngựa đội khác (trừ ô ★) thì húc lùi 3 ô.</a:t>
+              <a:t> bản đồ 6 cánh, vòng đua chung 42 ô + đường về nhà 4 ô; mỗi người một ngựa, tung 1 hoặc 6 để xuất chuồng; đáp xuống ô có ngựa đội khác (trừ ô ★) thì ĐÁ ngựa đó về chuồng, được tung thêm lượt.</a:t>
             </a:r>
           </a:p>
           <a:p>
@@ -11215,7 +11215,7 @@
                 </a:solidFill>
                 <a:latin typeface="Calibri"/>
               </a:rPr>
-              <a:t> 2-6 người chơi, mỗi người một ngựa trên một laptop; màn chiếu riêng cho lớp; 20-30 người cùng xem.</a:t>
+              <a:t> 6 đội, mỗi đội 1-6 người (mỗi người một ngựa, một laptop); màn chiếu riêng cho lớp; 20-30 người cùng chơi.</a:t>
             </a:r>
           </a:p>
         </p:txBody>

</xml_diff>

<commit_message>
vnr-v2: faster ten-minute game - 2 dice, 2-3 shared horses per team, horse choice, game clock
Pacing simulated first (40 bot games: 6 teams x 2 horses median 49 turns, p90 61).
Shorter track (30 ring + 3 lane), one horse starts out, doubles/kick/home give a
bonus roll, move phase with kick/home previews, 10-20 minute game limit.

Co-Authored-By: Claude Sonnet 5.5 <noreply@anthropic.com>
Claude-Session: https://claude.ai/code/session_01QTHbdfM1djtdfxn4szBzYR
</commit_message>
<xml_diff>
--- a/vnr-v2/slides/VNR202_CaNgua_Showcase_v2.pptx
+++ b/vnr-v2/slides/VNR202_CaNgua_Showcase_v2.pptx
@@ -4999,7 +4999,7 @@
                 </a:solidFill>
                 <a:latin typeface="Calibri"/>
               </a:rPr>
-              <a:t>6 đội, mỗi người một ngựa, đua trên bản đồ 6 cánh có chuồng</a:t>
+              <a:t>6 đội × 2-3 ngựa, 2 xúc xắc, chọn ngựa đi mỗi lượt</a:t>
             </a:r>
           </a:p>
           <a:p>
@@ -5015,7 +5015,7 @@
                 </a:solidFill>
                 <a:latin typeface="Calibri"/>
               </a:rPr>
-              <a:t>Xuất chuồng khi tung 1/6, đá ngựa về chuồng, tung thêm lượt</a:t>
+              <a:t>Ván tối đa 10-20 phút, đồng hồ trên đầu trang</a:t>
             </a:r>
           </a:p>
           <a:p>
@@ -11165,7 +11165,7 @@
                 </a:solidFill>
                 <a:latin typeface="Calibri"/>
               </a:rPr>
-              <a:t> bản đồ 6 cánh, vòng đua chung 42 ô + đường về nhà 4 ô; mỗi người một ngựa, tung 1 hoặc 6 để xuất chuồng; đáp xuống ô có ngựa đội khác (trừ ô ★) thì ĐÁ ngựa đó về chuồng, được tung thêm lượt.</a:t>
+              <a:t> bản đồ 6 cánh, vòng đua 30 ô + đường về nhà 3 ô; mỗi đội 2-3 ngựa dùng chung, tung 2 xúc xắc (đi theo tổng), một viên ra 1 hoặc 6 để xuất chuồng; đáp xuống ô có ngựa đội khác (trừ ô ★) thì ĐÁ ngựa đó về chuồng; hai viên giống nhau thì tung thêm.</a:t>
             </a:r>
           </a:p>
           <a:p>
@@ -11215,7 +11215,7 @@
                 </a:solidFill>
                 <a:latin typeface="Calibri"/>
               </a:rPr>
-              <a:t> 6 đội, mỗi đội 1-6 người (mỗi người một ngựa, một laptop); màn chiếu riêng cho lớp; 20-30 người cùng chơi.</a:t>
+              <a:t> 6 đội, mỗi đội 1-6 người (một laptop mỗi người); ván giới hạn 10-20 phút, đội đưa 2 ngựa về đích trước thắng; màn chiếu riêng cho lớp.</a:t>
             </a:r>
           </a:p>
         </p:txBody>
@@ -11486,7 +11486,7 @@
         <p:spPr>
           <a:xfrm>
             <a:off x="7040880" y="1463040"/>
-            <a:ext cx="4663440" cy="2914650"/>
+            <a:ext cx="4663440" cy="3954208"/>
           </a:xfrm>
           <a:prstGeom prst="rect">
             <a:avLst/>
@@ -11543,7 +11543,7 @@
                 </a:solidFill>
                 <a:latin typeface="Calibri"/>
               </a:rPr>
-              <a:t>Phòng chờ: mỗi người chọn 1 trong 6 ngựa. Trên laptop của mình, người chơi thấy câu hỏi, 4 đáp án và thẻ kỹ năng riêng (đối thủ chỉ thấy số thẻ).</a:t>
+              <a:t>Phòng chờ: mỗi người chọn 1 trong 6 đội. Trên laptop của mình, người chơi thấy câu hỏi, 4 đáp án, chọn ngựa đi và thẻ kỹ năng của đội (đối thủ chỉ thấy số thẻ).</a:t>
             </a:r>
           </a:p>
         </p:txBody>

</xml_diff>